<commit_message>
Presentación: capturas reales de la app y sin diapositiva de validación
- Nueva diapositiva 5 «La app, en el móvil» con capturas de la versión actual (Inicio, Ejercicio, «Me duele», Sesión registrada).
- Eliminada la diapositiva «Validación: todo en verde».

Co-Authored-By: Claude Opus 5.5 <noreply@anthropic.com>
Claude-Session: https://claude.ai/code/session_01UDp2wULQGn3fe34PAJLTRk
</commit_message>
<xml_diff>
--- a/Vitalis_Presentacion (2).pptx
+++ b/Vitalis_Presentacion (2).pptx
@@ -9,10 +9,10 @@
     <p:sldId id="257" r:id="rId3"/>
     <p:sldId id="258" r:id="rId4"/>
     <p:sldId id="259" r:id="rId5"/>
+    <p:sldId id="266" r:id="rId9"/>
     <p:sldId id="260" r:id="rId6"/>
     <p:sldId id="261" r:id="rId7"/>
     <p:sldId id="262" r:id="rId8"/>
-    <p:sldId id="263" r:id="rId9"/>
     <p:sldId id="264" r:id="rId10"/>
     <p:sldId id="265" r:id="rId11"/>
   </p:sldIdLst>
@@ -941,7 +941,7 @@
 </file>
 
 <file path=ppt/notesSlides/notesSlide5.xml><?xml version="1.0" encoding="utf-8"?>
-<p:notes xmlns:a="http://schemas.openxmlformats.org/drawingml/2006/main" xmlns:r="http://schemas.openxmlformats.org/officeDocument/2006/relationships" xmlns:p="http://schemas.openxmlformats.org/presentationml/2006/main">
+<p:notes xmlns:a="http://schemas.openxmlformats.org/drawingml/2006/main" xmlns:p="http://schemas.openxmlformats.org/presentationml/2006/main" xmlns:r="http://schemas.openxmlformats.org/officeDocument/2006/relationships">
   <p:cSld>
     <p:spTree>
       <p:nvGrpSpPr>
@@ -961,10 +961,10 @@
         <p:nvSpPr>
           <p:cNvPr id="2" name="Slide Image Placeholder 1"/>
           <p:cNvSpPr>
-            <a:spLocks noGrp="1" noRot="1" noChangeAspect="1"/>
+            <a:spLocks noGrp="1"/>
           </p:cNvSpPr>
           <p:nvPr>
-            <p:ph type="sldImg"/>
+            <p:ph type="sldImg" idx="2"/>
           </p:nvPr>
         </p:nvSpPr>
         <p:spPr/>
@@ -976,7 +976,7 @@
             <a:spLocks noGrp="1"/>
           </p:cNvSpPr>
           <p:nvPr>
-            <p:ph type="body" idx="1"/>
+            <p:ph type="body" idx="3" sz="quarter"/>
           </p:nvPr>
         </p:nvSpPr>
         <p:spPr/>
@@ -985,10 +985,8 @@
           <a:lstStyle/>
           <a:p>
             <a:r>
-              <a:rPr lang="en-US" dirty="0"/>
-              <a:t>Todo el diseño parte de la usuaria: botones de al menos 48 píxeles, texto de 18, contraste 4,5 a 1 según WCAG. Los estados siempre con icono y texto, nunca solo color. Todo el flujo se puede hacer con teclado y el lenguaje es llano.</a:t>
-            </a:r>
-            <a:endParaRPr lang="en-US" dirty="0"/>
+              <a:t>Así se ve la app de verdad, en un iPhone: son capturas de la versión validada, no del diseño. En Inicio, Rosa ve su sesión del día y un único botón grande para empezar. En Ejercicio aparece primero la preparación del espacio y después los pasos. El botón «Me duele» está siempre a la vista: lleva a una pausa que no cuenta como sesión hecha. Y al terminar, la sesión queda registrada en el móvil y puede avisar a su familia.</a:t>
+            </a:r>
           </a:p>
         </p:txBody>
       </p:sp>
@@ -999,28 +997,12 @@
             <a:spLocks noGrp="1"/>
           </p:cNvSpPr>
           <p:nvPr>
-            <p:ph type="sldNum" sz="quarter" idx="10"/>
+            <p:ph type="sldNum" idx="5" sz="quarter"/>
           </p:nvPr>
         </p:nvSpPr>
         <p:spPr/>
-        <p:txBody>
-          <a:bodyPr/>
-          <a:lstStyle/>
-          <a:p>
-            <a:fld id="{F7021451-1387-4CA6-816F-3879F97B5CBC}" type="slidenum">
-              <a:rPr lang="en-US"/>
-              <a:t>5</a:t>
-            </a:fld>
-            <a:endParaRPr lang="en-US"/>
-          </a:p>
-        </p:txBody>
       </p:sp>
     </p:spTree>
-    <p:extLst>
-      <p:ext uri="{BB962C8B-B14F-4D97-AF65-F5344CB8AC3E}">
-        <p14:creationId xmlns:p14="http://schemas.microsoft.com/office/powerpoint/2010/main" val="1024086991"/>
-      </p:ext>
-    </p:extLst>
   </p:cSld>
   <p:clrMapOvr>
     <a:masterClrMapping/>
@@ -1074,7 +1056,7 @@
           <a:p>
             <a:r>
               <a:rPr lang="en-US" dirty="0"/>
-              <a:t>No hay servidor, ni cuentas, ni analíticas, ni peticiones a terceros: los registros se guardan en el propio dispositivo. No se guardan nombres, contactos ni datos de salud. Avisar a la familia usa la hoja de compartir del sistema, así que ella elige a quién y nosotros nunca tocamos sus contactos.</a:t>
+              <a:t>Todo el diseño parte de la usuaria: botones de al menos 48 píxeles, texto de 18, contraste 4,5 a 1 según WCAG. Los estados siempre con icono y texto, nunca solo color. Todo el flujo se puede hacer con teclado y el lenguaje es llano.</a:t>
             </a:r>
             <a:endParaRPr lang="en-US" dirty="0"/>
           </a:p>
@@ -1097,7 +1079,7 @@
           <a:p>
             <a:fld id="{F7021451-1387-4CA6-816F-3879F97B5CBC}" type="slidenum">
               <a:rPr lang="en-US"/>
-              <a:t>6</a:t>
+              <a:t>5</a:t>
             </a:fld>
             <a:endParaRPr lang="en-US"/>
           </a:p>
@@ -1162,7 +1144,7 @@
           <a:p>
             <a:r>
               <a:rPr lang="en-US" dirty="0"/>
-              <a:t>Elegimos lo más pequeño que cumple la especificación: una app web para móvil con React y TypeScript, sin servidor. Tres capas: pantallas, lógica con una máquina de estados, y datos detrás de un repositorio, de modo que mañana se podría cambiar localStorage por una API sin tocar las pantallas.</a:t>
+              <a:t>No hay servidor, ni cuentas, ni analíticas, ni peticiones a terceros: los registros se guardan en el propio dispositivo. No se guardan nombres, contactos ni datos de salud. Avisar a la familia usa la hoja de compartir del sistema, así que ella elige a quién y nosotros nunca tocamos sus contactos.</a:t>
             </a:r>
             <a:endParaRPr lang="en-US" dirty="0"/>
           </a:p>
@@ -1185,7 +1167,7 @@
           <a:p>
             <a:fld id="{F7021451-1387-4CA6-816F-3879F97B5CBC}" type="slidenum">
               <a:rPr lang="en-US"/>
-              <a:t>7</a:t>
+              <a:t>6</a:t>
             </a:fld>
             <a:endParaRPr lang="en-US"/>
           </a:p>
@@ -1250,7 +1232,7 @@
           <a:p>
             <a:r>
               <a:rPr lang="en-US" dirty="0"/>
-              <a:t>Con un solo comando, npm run check, se ejecutan lint, tipos, contraste, unitarios y e2e. Son 107 comprobaciones en verde: 51 unitarias y 28 e2e en dos perfiles de móvil, Android e iPhone. La auditoría de accesibilidad con axe no da ninguna violación grave. Cada test lleva en el nombre el ID del requisito que valida.</a:t>
+              <a:t>Elegimos lo más pequeño que cumple la especificación: una app web para móvil con React y TypeScript, sin servidor. Tres capas: pantallas, lógica con una máquina de estados, y datos detrás de un repositorio, de modo que mañana se podría cambiar localStorage por una API sin tocar las pantallas.</a:t>
             </a:r>
             <a:endParaRPr lang="en-US" dirty="0"/>
           </a:p>
@@ -1273,7 +1255,7 @@
           <a:p>
             <a:fld id="{F7021451-1387-4CA6-816F-3879F97B5CBC}" type="slidenum">
               <a:rPr lang="en-US"/>
-              <a:t>8</a:t>
+              <a:t>7</a:t>
             </a:fld>
             <a:endParaRPr lang="en-US"/>
           </a:p>
@@ -4758,6 +4740,679 @@
 </file>
 
 <file path=ppt/slides/slide5.xml><?xml version="1.0" encoding="utf-8"?>
+<p:sld xmlns:a="http://schemas.openxmlformats.org/drawingml/2006/main" xmlns:p="http://schemas.openxmlformats.org/presentationml/2006/main" xmlns:r="http://schemas.openxmlformats.org/officeDocument/2006/relationships">
+  <p:cSld>
+    <p:spTree>
+      <p:nvGrpSpPr>
+        <p:cNvPr id="1" name=""/>
+        <p:cNvGrpSpPr/>
+        <p:nvPr/>
+      </p:nvGrpSpPr>
+      <p:grpSpPr/>
+      <p:sp>
+        <p:nvSpPr>
+          <p:cNvPr id="2" name="Text 0"/>
+          <p:cNvSpPr/>
+          <p:nvPr>
+            <p:ph idx="100" type="title" hasCustomPrompt="1"/>
+          </p:nvPr>
+        </p:nvSpPr>
+        <p:spPr>
+          <a:xfrm>
+            <a:off x="548640" y="320040"/>
+            <a:ext cx="8046720" cy="777240"/>
+          </a:xfrm>
+          <a:prstGeom prst="rect">
+            <a:avLst/>
+          </a:prstGeom>
+          <a:noFill/>
+          <a:ln/>
+        </p:spPr>
+        <p:txBody>
+          <a:bodyPr wrap="square" lIns="0" tIns="0" rIns="0" bIns="0" rtlCol="0" anchor="ctr"/>
+          <a:lstStyle/>
+          <a:p>
+            <a:pPr algn="l" indent="0" marL="0">
+              <a:buNone/>
+            </a:pPr>
+            <a:r>
+              <a:rPr lang="en-US" sz="3400" b="1" dirty="0">
+                <a:solidFill>
+                  <a:schemeClr val="tx2"/>
+                </a:solidFill>
+              </a:rPr>
+              <a:t>La app, en el móvil</a:t>
+            </a:r>
+            <a:endParaRPr lang="en-US" sz="3400" dirty="0"/>
+          </a:p>
+        </p:txBody>
+      </p:sp>
+      <p:sp>
+        <p:nvSpPr>
+          <p:cNvPr id="25" name="Slide Number Placeholder 0"/>
+          <p:cNvSpPr>
+            <a:spLocks noGrp="1"/>
+          </p:cNvSpPr>
+          <p:nvPr>
+            <p:ph type="sldNum" sz="quarter" idx="4294967295"/>
+          </p:nvPr>
+        </p:nvSpPr>
+        <p:spPr>
+          <a:xfrm>
+            <a:off x="8138160" y="4736592"/>
+            <a:ext cx="457200" cy="274320"/>
+          </a:xfrm>
+          <a:prstGeom prst="rect">
+            <a:avLst/>
+          </a:prstGeom>
+          <a:extLst>
+            <a:ext uri="{C572A759-6A51-4108-AA02-DFA0A04FC94B}">
+              <ma14:wrappingTextBoxFlag xmlns:ma14="http://schemas.microsoft.com/office/mac/drawingml/2011/main" val="0"/>
+            </a:ext>
+          </a:extLst>
+        </p:spPr>
+        <p:txBody>
+          <a:bodyPr/>
+          <a:lstStyle>
+            <a:lvl1pPr>
+              <a:defRPr sz="1000">
+                <a:solidFill>
+                  <a:schemeClr val="accent6"/>
+                </a:solidFill>
+              </a:defRPr>
+            </a:lvl1pPr>
+          </a:lstStyle>
+          <a:p>
+            <a:pPr algn="r"/>
+            <a:fld id="{F7021451-1387-4CA6-816F-3879F97B5CBC}" type="slidenum">
+              <a:rPr b="0" lang="en-US"/>
+              <a:t>9</a:t>
+            </a:fld>
+            <a:endParaRPr lang="en-US"/>
+          </a:p>
+        </p:txBody>
+      </p:sp>
+      <p:pic>
+        <p:nvPicPr>
+          <p:cNvPr id="26" name="Pantalla 1: Inicio" descr="Captura real de la pantalla Inicio de Vitalis en un iPhone"/>
+          <p:cNvPicPr>
+            <a:picLocks noChangeAspect="1"/>
+          </p:cNvPicPr>
+          <p:nvPr/>
+        </p:nvPicPr>
+        <p:blipFill>
+          <a:blip r:embed="rId2"/>
+          <a:stretch>
+            <a:fillRect/>
+          </a:stretch>
+        </p:blipFill>
+        <p:spPr>
+          <a:xfrm>
+            <a:off x="841171" y="1078992"/>
+            <a:ext cx="1426617" cy="2788920"/>
+          </a:xfrm>
+          <a:prstGeom prst="rect">
+            <a:avLst/>
+          </a:prstGeom>
+        </p:spPr>
+      </p:pic>
+      <p:sp>
+        <p:nvSpPr>
+          <p:cNvPr id="27" name="Número 1"/>
+          <p:cNvSpPr/>
+          <p:nvPr/>
+        </p:nvSpPr>
+        <p:spPr>
+          <a:xfrm>
+            <a:off x="713232" y="3959352"/>
+            <a:ext cx="274320" cy="274320"/>
+          </a:xfrm>
+          <a:prstGeom prst="ellipse">
+            <a:avLst/>
+          </a:prstGeom>
+          <a:solidFill>
+            <a:srgbClr val="B4481A"/>
+          </a:solidFill>
+          <a:ln>
+            <a:noFill/>
+          </a:ln>
+        </p:spPr>
+        <p:style>
+          <a:lnRef idx="1">
+            <a:schemeClr val="accent1"/>
+          </a:lnRef>
+          <a:fillRef idx="3">
+            <a:schemeClr val="accent1"/>
+          </a:fillRef>
+          <a:effectRef idx="2">
+            <a:schemeClr val="accent1"/>
+          </a:effectRef>
+          <a:fontRef idx="minor">
+            <a:schemeClr val="lt1"/>
+          </a:fontRef>
+        </p:style>
+        <p:txBody>
+          <a:bodyPr rtlCol="0" anchor="ctr" lIns="0" rIns="0" tIns="0" bIns="0"/>
+          <a:lstStyle/>
+          <a:p>
+            <a:pPr algn="ctr"/>
+            <a:r>
+              <a:rPr sz="1200" b="1">
+                <a:solidFill>
+                  <a:srgbClr val="FFFFFF"/>
+                </a:solidFill>
+              </a:rPr>
+              <a:t>1</a:t>
+            </a:r>
+          </a:p>
+        </p:txBody>
+      </p:sp>
+      <p:sp>
+        <p:nvSpPr>
+          <p:cNvPr id="28" name="Título pantalla 1"/>
+          <p:cNvSpPr txBox="1"/>
+          <p:nvPr/>
+        </p:nvSpPr>
+        <p:spPr>
+          <a:xfrm>
+            <a:off x="1060704" y="3941063"/>
+            <a:ext cx="1371600" cy="274320"/>
+          </a:xfrm>
+          <a:prstGeom prst="rect">
+            <a:avLst/>
+          </a:prstGeom>
+          <a:noFill/>
+        </p:spPr>
+        <p:txBody>
+          <a:bodyPr wrap="square" lIns="0" rIns="0" tIns="0" bIns="0" anchor="ctr">
+            <a:spAutoFit/>
+          </a:bodyPr>
+          <a:lstStyle/>
+          <a:p>
+            <a:pPr algn="l"/>
+            <a:r>
+              <a:rPr sz="1300" b="1">
+                <a:solidFill>
+                  <a:srgbClr val="16294A"/>
+                </a:solidFill>
+              </a:rPr>
+              <a:t>Inicio</a:t>
+            </a:r>
+          </a:p>
+        </p:txBody>
+      </p:sp>
+      <p:sp>
+        <p:nvSpPr>
+          <p:cNvPr id="29" name="Texto pantalla 1"/>
+          <p:cNvSpPr txBox="1"/>
+          <p:nvPr/>
+        </p:nvSpPr>
+        <p:spPr>
+          <a:xfrm>
+            <a:off x="713232" y="4261104"/>
+            <a:ext cx="1719072" cy="365760"/>
+          </a:xfrm>
+          <a:prstGeom prst="rect">
+            <a:avLst/>
+          </a:prstGeom>
+          <a:noFill/>
+        </p:spPr>
+        <p:txBody>
+          <a:bodyPr wrap="square" lIns="0" rIns="0" tIns="0" bIns="0" anchor="t">
+            <a:spAutoFit/>
+          </a:bodyPr>
+          <a:lstStyle/>
+          <a:p>
+            <a:pPr algn="l"/>
+            <a:r>
+              <a:rPr sz="1050" b="0">
+                <a:solidFill>
+                  <a:srgbClr val="4D566D"/>
+                </a:solidFill>
+              </a:rPr>
+              <a:t>Su sesión del día, pendiente o hecha</a:t>
+            </a:r>
+          </a:p>
+        </p:txBody>
+      </p:sp>
+      <p:pic>
+        <p:nvPicPr>
+          <p:cNvPr id="30" name="Pantalla 2: Ejercicio" descr="Captura real de la pantalla Ejercicio de Vitalis en un iPhone"/>
+          <p:cNvPicPr>
+            <a:picLocks noChangeAspect="1"/>
+          </p:cNvPicPr>
+          <p:nvPr/>
+        </p:nvPicPr>
+        <p:blipFill>
+          <a:blip r:embed="rId3"/>
+          <a:stretch>
+            <a:fillRect/>
+          </a:stretch>
+        </p:blipFill>
+        <p:spPr>
+          <a:xfrm>
+            <a:off x="2852851" y="1078992"/>
+            <a:ext cx="1426617" cy="2788920"/>
+          </a:xfrm>
+          <a:prstGeom prst="rect">
+            <a:avLst/>
+          </a:prstGeom>
+        </p:spPr>
+      </p:pic>
+      <p:sp>
+        <p:nvSpPr>
+          <p:cNvPr id="31" name="Número 2"/>
+          <p:cNvSpPr/>
+          <p:nvPr/>
+        </p:nvSpPr>
+        <p:spPr>
+          <a:xfrm>
+            <a:off x="2724912" y="3959352"/>
+            <a:ext cx="274320" cy="274320"/>
+          </a:xfrm>
+          <a:prstGeom prst="ellipse">
+            <a:avLst/>
+          </a:prstGeom>
+          <a:solidFill>
+            <a:srgbClr val="B4481A"/>
+          </a:solidFill>
+          <a:ln>
+            <a:noFill/>
+          </a:ln>
+        </p:spPr>
+        <p:style>
+          <a:lnRef idx="1">
+            <a:schemeClr val="accent1"/>
+          </a:lnRef>
+          <a:fillRef idx="3">
+            <a:schemeClr val="accent1"/>
+          </a:fillRef>
+          <a:effectRef idx="2">
+            <a:schemeClr val="accent1"/>
+          </a:effectRef>
+          <a:fontRef idx="minor">
+            <a:schemeClr val="lt1"/>
+          </a:fontRef>
+        </p:style>
+        <p:txBody>
+          <a:bodyPr rtlCol="0" anchor="ctr" lIns="0" rIns="0" tIns="0" bIns="0"/>
+          <a:lstStyle/>
+          <a:p>
+            <a:pPr algn="ctr"/>
+            <a:r>
+              <a:rPr sz="1200" b="1">
+                <a:solidFill>
+                  <a:srgbClr val="FFFFFF"/>
+                </a:solidFill>
+              </a:rPr>
+              <a:t>2</a:t>
+            </a:r>
+          </a:p>
+        </p:txBody>
+      </p:sp>
+      <p:sp>
+        <p:nvSpPr>
+          <p:cNvPr id="32" name="Título pantalla 2"/>
+          <p:cNvSpPr txBox="1"/>
+          <p:nvPr/>
+        </p:nvSpPr>
+        <p:spPr>
+          <a:xfrm>
+            <a:off x="3072384" y="3941063"/>
+            <a:ext cx="1371600" cy="274320"/>
+          </a:xfrm>
+          <a:prstGeom prst="rect">
+            <a:avLst/>
+          </a:prstGeom>
+          <a:noFill/>
+        </p:spPr>
+        <p:txBody>
+          <a:bodyPr wrap="square" lIns="0" rIns="0" tIns="0" bIns="0" anchor="ctr">
+            <a:spAutoFit/>
+          </a:bodyPr>
+          <a:lstStyle/>
+          <a:p>
+            <a:pPr algn="l"/>
+            <a:r>
+              <a:rPr sz="1300" b="1">
+                <a:solidFill>
+                  <a:srgbClr val="16294A"/>
+                </a:solidFill>
+              </a:rPr>
+              <a:t>Ejercicio</a:t>
+            </a:r>
+          </a:p>
+        </p:txBody>
+      </p:sp>
+      <p:sp>
+        <p:nvSpPr>
+          <p:cNvPr id="33" name="Texto pantalla 2"/>
+          <p:cNvSpPr txBox="1"/>
+          <p:nvPr/>
+        </p:nvSpPr>
+        <p:spPr>
+          <a:xfrm>
+            <a:off x="2724912" y="4261104"/>
+            <a:ext cx="1719072" cy="365760"/>
+          </a:xfrm>
+          <a:prstGeom prst="rect">
+            <a:avLst/>
+          </a:prstGeom>
+          <a:noFill/>
+        </p:spPr>
+        <p:txBody>
+          <a:bodyPr wrap="square" lIns="0" rIns="0" tIns="0" bIns="0" anchor="t">
+            <a:spAutoFit/>
+          </a:bodyPr>
+          <a:lstStyle/>
+          <a:p>
+            <a:pPr algn="l"/>
+            <a:r>
+              <a:rPr sz="1050" b="0">
+                <a:solidFill>
+                  <a:srgbClr val="4D566D"/>
+                </a:solidFill>
+              </a:rPr>
+              <a:t>Primero la preparación, luego los pasos</a:t>
+            </a:r>
+          </a:p>
+        </p:txBody>
+      </p:sp>
+      <p:pic>
+        <p:nvPicPr>
+          <p:cNvPr id="34" name="Pantalla 3: «Me duele»" descr="Captura real de la pantalla «Me duele» de Vitalis en un iPhone"/>
+          <p:cNvPicPr>
+            <a:picLocks noChangeAspect="1"/>
+          </p:cNvPicPr>
+          <p:nvPr/>
+        </p:nvPicPr>
+        <p:blipFill>
+          <a:blip r:embed="rId4"/>
+          <a:stretch>
+            <a:fillRect/>
+          </a:stretch>
+        </p:blipFill>
+        <p:spPr>
+          <a:xfrm>
+            <a:off x="4864531" y="1078992"/>
+            <a:ext cx="1426617" cy="2788920"/>
+          </a:xfrm>
+          <a:prstGeom prst="rect">
+            <a:avLst/>
+          </a:prstGeom>
+        </p:spPr>
+      </p:pic>
+      <p:sp>
+        <p:nvSpPr>
+          <p:cNvPr id="35" name="Número 3"/>
+          <p:cNvSpPr/>
+          <p:nvPr/>
+        </p:nvSpPr>
+        <p:spPr>
+          <a:xfrm>
+            <a:off x="4736592" y="3959352"/>
+            <a:ext cx="274320" cy="274320"/>
+          </a:xfrm>
+          <a:prstGeom prst="ellipse">
+            <a:avLst/>
+          </a:prstGeom>
+          <a:solidFill>
+            <a:srgbClr val="B4481A"/>
+          </a:solidFill>
+          <a:ln>
+            <a:noFill/>
+          </a:ln>
+        </p:spPr>
+        <p:style>
+          <a:lnRef idx="1">
+            <a:schemeClr val="accent1"/>
+          </a:lnRef>
+          <a:fillRef idx="3">
+            <a:schemeClr val="accent1"/>
+          </a:fillRef>
+          <a:effectRef idx="2">
+            <a:schemeClr val="accent1"/>
+          </a:effectRef>
+          <a:fontRef idx="minor">
+            <a:schemeClr val="lt1"/>
+          </a:fontRef>
+        </p:style>
+        <p:txBody>
+          <a:bodyPr rtlCol="0" anchor="ctr" lIns="0" rIns="0" tIns="0" bIns="0"/>
+          <a:lstStyle/>
+          <a:p>
+            <a:pPr algn="ctr"/>
+            <a:r>
+              <a:rPr sz="1200" b="1">
+                <a:solidFill>
+                  <a:srgbClr val="FFFFFF"/>
+                </a:solidFill>
+              </a:rPr>
+              <a:t>3</a:t>
+            </a:r>
+          </a:p>
+        </p:txBody>
+      </p:sp>
+      <p:sp>
+        <p:nvSpPr>
+          <p:cNvPr id="36" name="Título pantalla 3"/>
+          <p:cNvSpPr txBox="1"/>
+          <p:nvPr/>
+        </p:nvSpPr>
+        <p:spPr>
+          <a:xfrm>
+            <a:off x="5084064" y="3941063"/>
+            <a:ext cx="1371600" cy="274320"/>
+          </a:xfrm>
+          <a:prstGeom prst="rect">
+            <a:avLst/>
+          </a:prstGeom>
+          <a:noFill/>
+        </p:spPr>
+        <p:txBody>
+          <a:bodyPr wrap="square" lIns="0" rIns="0" tIns="0" bIns="0" anchor="ctr">
+            <a:spAutoFit/>
+          </a:bodyPr>
+          <a:lstStyle/>
+          <a:p>
+            <a:pPr algn="l"/>
+            <a:r>
+              <a:rPr sz="1300" b="1">
+                <a:solidFill>
+                  <a:srgbClr val="16294A"/>
+                </a:solidFill>
+              </a:rPr>
+              <a:t>«Me duele»</a:t>
+            </a:r>
+          </a:p>
+        </p:txBody>
+      </p:sp>
+      <p:sp>
+        <p:nvSpPr>
+          <p:cNvPr id="37" name="Texto pantalla 3"/>
+          <p:cNvSpPr txBox="1"/>
+          <p:nvPr/>
+        </p:nvSpPr>
+        <p:spPr>
+          <a:xfrm>
+            <a:off x="4736592" y="4261104"/>
+            <a:ext cx="1719072" cy="365760"/>
+          </a:xfrm>
+          <a:prstGeom prst="rect">
+            <a:avLst/>
+          </a:prstGeom>
+          <a:noFill/>
+        </p:spPr>
+        <p:txBody>
+          <a:bodyPr wrap="square" lIns="0" rIns="0" tIns="0" bIns="0" anchor="t">
+            <a:spAutoFit/>
+          </a:bodyPr>
+          <a:lstStyle/>
+          <a:p>
+            <a:pPr algn="l"/>
+            <a:r>
+              <a:rPr sz="1050" b="0">
+                <a:solidFill>
+                  <a:srgbClr val="4D566D"/>
+                </a:solidFill>
+              </a:rPr>
+              <a:t>Siempre visible: pausa sin registrar</a:t>
+            </a:r>
+          </a:p>
+        </p:txBody>
+      </p:sp>
+      <p:pic>
+        <p:nvPicPr>
+          <p:cNvPr id="38" name="Pantalla 4: Registrada" descr="Captura real de la pantalla Registrada de Vitalis en un iPhone"/>
+          <p:cNvPicPr>
+            <a:picLocks noChangeAspect="1"/>
+          </p:cNvPicPr>
+          <p:nvPr/>
+        </p:nvPicPr>
+        <p:blipFill>
+          <a:blip r:embed="rId5"/>
+          <a:stretch>
+            <a:fillRect/>
+          </a:stretch>
+        </p:blipFill>
+        <p:spPr>
+          <a:xfrm>
+            <a:off x="6876211" y="1078992"/>
+            <a:ext cx="1426617" cy="2788920"/>
+          </a:xfrm>
+          <a:prstGeom prst="rect">
+            <a:avLst/>
+          </a:prstGeom>
+        </p:spPr>
+      </p:pic>
+      <p:sp>
+        <p:nvSpPr>
+          <p:cNvPr id="39" name="Número 4"/>
+          <p:cNvSpPr/>
+          <p:nvPr/>
+        </p:nvSpPr>
+        <p:spPr>
+          <a:xfrm>
+            <a:off x="6748272" y="3959352"/>
+            <a:ext cx="274320" cy="274320"/>
+          </a:xfrm>
+          <a:prstGeom prst="ellipse">
+            <a:avLst/>
+          </a:prstGeom>
+          <a:solidFill>
+            <a:srgbClr val="B4481A"/>
+          </a:solidFill>
+          <a:ln>
+            <a:noFill/>
+          </a:ln>
+        </p:spPr>
+        <p:style>
+          <a:lnRef idx="1">
+            <a:schemeClr val="accent1"/>
+          </a:lnRef>
+          <a:fillRef idx="3">
+            <a:schemeClr val="accent1"/>
+          </a:fillRef>
+          <a:effectRef idx="2">
+            <a:schemeClr val="accent1"/>
+          </a:effectRef>
+          <a:fontRef idx="minor">
+            <a:schemeClr val="lt1"/>
+          </a:fontRef>
+        </p:style>
+        <p:txBody>
+          <a:bodyPr rtlCol="0" anchor="ctr" lIns="0" rIns="0" tIns="0" bIns="0"/>
+          <a:lstStyle/>
+          <a:p>
+            <a:pPr algn="ctr"/>
+            <a:r>
+              <a:rPr sz="1200" b="1">
+                <a:solidFill>
+                  <a:srgbClr val="FFFFFF"/>
+                </a:solidFill>
+              </a:rPr>
+              <a:t>4</a:t>
+            </a:r>
+          </a:p>
+        </p:txBody>
+      </p:sp>
+      <p:sp>
+        <p:nvSpPr>
+          <p:cNvPr id="40" name="Título pantalla 4"/>
+          <p:cNvSpPr txBox="1"/>
+          <p:nvPr/>
+        </p:nvSpPr>
+        <p:spPr>
+          <a:xfrm>
+            <a:off x="7095744" y="3941063"/>
+            <a:ext cx="1371600" cy="274320"/>
+          </a:xfrm>
+          <a:prstGeom prst="rect">
+            <a:avLst/>
+          </a:prstGeom>
+          <a:noFill/>
+        </p:spPr>
+        <p:txBody>
+          <a:bodyPr wrap="square" lIns="0" rIns="0" tIns="0" bIns="0" anchor="ctr">
+            <a:spAutoFit/>
+          </a:bodyPr>
+          <a:lstStyle/>
+          <a:p>
+            <a:pPr algn="l"/>
+            <a:r>
+              <a:rPr sz="1300" b="1">
+                <a:solidFill>
+                  <a:srgbClr val="16294A"/>
+                </a:solidFill>
+              </a:rPr>
+              <a:t>Registrada</a:t>
+            </a:r>
+          </a:p>
+        </p:txBody>
+      </p:sp>
+      <p:sp>
+        <p:nvSpPr>
+          <p:cNvPr id="41" name="Texto pantalla 4"/>
+          <p:cNvSpPr txBox="1"/>
+          <p:nvPr/>
+        </p:nvSpPr>
+        <p:spPr>
+          <a:xfrm>
+            <a:off x="6748272" y="4261104"/>
+            <a:ext cx="1719072" cy="365760"/>
+          </a:xfrm>
+          <a:prstGeom prst="rect">
+            <a:avLst/>
+          </a:prstGeom>
+          <a:noFill/>
+        </p:spPr>
+        <p:txBody>
+          <a:bodyPr wrap="square" lIns="0" rIns="0" tIns="0" bIns="0" anchor="t">
+            <a:spAutoFit/>
+          </a:bodyPr>
+          <a:lstStyle/>
+          <a:p>
+            <a:pPr algn="l"/>
+            <a:r>
+              <a:rPr sz="1050" b="0">
+                <a:solidFill>
+                  <a:srgbClr val="4D566D"/>
+                </a:solidFill>
+              </a:rPr>
+              <a:t>Guardada en el móvil y aviso a la familia</a:t>
+            </a:r>
+          </a:p>
+        </p:txBody>
+      </p:sp>
+    </p:spTree>
+  </p:cSld>
+  <p:clrMapOvr>
+    <a:masterClrMapping/>
+  </p:clrMapOvr>
+</p:sld>
+</file>
+
+<file path=ppt/slides/slide6.xml><?xml version="1.0" encoding="utf-8"?>
 <p:sld xmlns:a="http://schemas.openxmlformats.org/drawingml/2006/main" xmlns:r="http://schemas.openxmlformats.org/officeDocument/2006/relationships" xmlns:p="http://schemas.openxmlformats.org/presentationml/2006/main">
   <p:cSld name="Slide 5">
     <p:spTree>
@@ -5514,7 +6169,7 @@
 </p:sld>
 </file>
 
-<file path=ppt/slides/slide6.xml><?xml version="1.0" encoding="utf-8"?>
+<file path=ppt/slides/slide7.xml><?xml version="1.0" encoding="utf-8"?>
 <p:sld xmlns:a="http://schemas.openxmlformats.org/drawingml/2006/main" xmlns:r="http://schemas.openxmlformats.org/officeDocument/2006/relationships" xmlns:p="http://schemas.openxmlformats.org/presentationml/2006/main">
   <p:cSld name="Slide 6">
     <p:spTree>
@@ -6252,7 +6907,7 @@
 </p:sld>
 </file>
 
-<file path=ppt/slides/slide7.xml><?xml version="1.0" encoding="utf-8"?>
+<file path=ppt/slides/slide8.xml><?xml version="1.0" encoding="utf-8"?>
 <p:sld xmlns:a="http://schemas.openxmlformats.org/drawingml/2006/main" xmlns:r="http://schemas.openxmlformats.org/officeDocument/2006/relationships" xmlns:p="http://schemas.openxmlformats.org/presentationml/2006/main">
   <p:cSld name="Slide 7">
     <p:spTree>
@@ -7351,695 +8006,6 @@
             <a:fld id="{F7021451-1387-4CA6-816F-3879F97B5CBC}" type="slidenum">
               <a:rPr b="0" lang="en-US"/>
               <a:t>7</a:t>
-            </a:fld>
-            <a:endParaRPr lang="en-US"/>
-          </a:p>
-        </p:txBody>
-      </p:sp>
-    </p:spTree>
-  </p:cSld>
-  <p:clrMapOvr>
-    <a:masterClrMapping/>
-  </p:clrMapOvr>
-</p:sld>
-</file>
-
-<file path=ppt/slides/slide8.xml><?xml version="1.0" encoding="utf-8"?>
-<p:sld xmlns:a="http://schemas.openxmlformats.org/drawingml/2006/main" xmlns:r="http://schemas.openxmlformats.org/officeDocument/2006/relationships" xmlns:p="http://schemas.openxmlformats.org/presentationml/2006/main">
-  <p:cSld name="Slide 8">
-    <p:spTree>
-      <p:nvGrpSpPr>
-        <p:cNvPr id="1" name=""/>
-        <p:cNvGrpSpPr/>
-        <p:nvPr/>
-      </p:nvGrpSpPr>
-      <p:grpSpPr>
-        <a:xfrm>
-          <a:off x="0" y="0"/>
-          <a:ext cx="0" cy="0"/>
-          <a:chOff x="0" y="0"/>
-          <a:chExt cx="0" cy="0"/>
-        </a:xfrm>
-      </p:grpSpPr>
-      <p:sp>
-        <p:nvSpPr>
-          <p:cNvPr id="2" name="Text 0"/>
-          <p:cNvSpPr/>
-          <p:nvPr>
-            <p:ph idx="100" type="title" hasCustomPrompt="1"/>
-          </p:nvPr>
-        </p:nvSpPr>
-        <p:spPr>
-          <a:xfrm>
-            <a:off x="548640" y="320040"/>
-            <a:ext cx="8046720" cy="777240"/>
-          </a:xfrm>
-          <a:prstGeom prst="rect">
-            <a:avLst/>
-          </a:prstGeom>
-          <a:noFill/>
-          <a:ln/>
-        </p:spPr>
-        <p:txBody>
-          <a:bodyPr wrap="square" lIns="0" tIns="0" rIns="0" bIns="0" rtlCol="0" anchor="ctr"/>
-          <a:lstStyle/>
-          <a:p>
-            <a:pPr algn="l" indent="0" marL="0">
-              <a:buNone/>
-            </a:pPr>
-            <a:r>
-              <a:rPr lang="en-US" sz="3400" b="1" dirty="0">
-                <a:solidFill>
-                  <a:schemeClr val="tx2"/>
-                </a:solidFill>
-              </a:rPr>
-              <a:t>Validación: todo en verde</a:t>
-            </a:r>
-            <a:endParaRPr lang="en-US" sz="3400" dirty="0"/>
-          </a:p>
-        </p:txBody>
-      </p:sp>
-      <p:sp>
-        <p:nvSpPr>
-          <p:cNvPr id="3" name="Total pruebas"/>
-          <p:cNvSpPr/>
-          <p:nvPr/>
-        </p:nvSpPr>
-        <p:spPr>
-          <a:xfrm>
-            <a:off x="548640" y="1325880"/>
-            <a:ext cx="2743200" cy="3017520"/>
-          </a:xfrm>
-          <a:prstGeom prst="roundRect">
-            <a:avLst>
-              <a:gd name="adj" fmla="val 4000"/>
-            </a:avLst>
-          </a:prstGeom>
-          <a:solidFill>
-            <a:schemeClr val="tx2"/>
-          </a:solidFill>
-          <a:ln w="12700">
-            <a:solidFill>
-              <a:schemeClr val="bg1"/>
-            </a:solidFill>
-            <a:prstDash val="solid"/>
-          </a:ln>
-          <a:effectLst>
-            <a:outerShdw sx="100000" sy="100000" kx="0" ky="0" algn="bl" rotWithShape="0" blurRad="101600" dist="25400" dir="5400000">
-              <a:srgbClr val="000000">
-                <a:alpha val="12000"/>
-              </a:srgbClr>
-            </a:outerShdw>
-          </a:effectLst>
-        </p:spPr>
-      </p:sp>
-      <p:sp>
-        <p:nvSpPr>
-          <p:cNvPr id="4" name="Total cifra"/>
-          <p:cNvSpPr txBox="1"/>
-          <p:nvPr/>
-        </p:nvSpPr>
-        <p:spPr>
-          <a:xfrm>
-            <a:off x="777240" y="1645920"/>
-            <a:ext cx="2286000" cy="1188720"/>
-          </a:xfrm>
-          <a:prstGeom prst="rect">
-            <a:avLst/>
-          </a:prstGeom>
-          <a:noFill/>
-          <a:ln/>
-        </p:spPr>
-        <p:txBody>
-          <a:bodyPr wrap="square" lIns="0" tIns="0" rIns="0" bIns="0" rtlCol="0" anchor="ctr"/>
-          <a:lstStyle/>
-          <a:p>
-            <a:pPr indent="0" marL="0">
-              <a:buNone/>
-            </a:pPr>
-            <a:r>
-              <a:rPr lang="en-US" sz="7200" b="1" dirty="0">
-                <a:solidFill>
-                  <a:schemeClr val="bg1"/>
-                </a:solidFill>
-                <a:latin typeface="Cambria" pitchFamily="34" charset="0"/>
-                <a:ea typeface="Cambria" pitchFamily="34" charset="-122"/>
-                <a:cs typeface="Cambria" pitchFamily="34" charset="-120"/>
-              </a:rPr>
-              <a:t>107</a:t>
-            </a:r>
-            <a:endParaRPr lang="en-US" sz="7200" dirty="0"/>
-          </a:p>
-        </p:txBody>
-      </p:sp>
-      <p:sp>
-        <p:nvSpPr>
-          <p:cNvPr id="5" name="Total texto"/>
-          <p:cNvSpPr txBox="1"/>
-          <p:nvPr/>
-        </p:nvSpPr>
-        <p:spPr>
-          <a:xfrm>
-            <a:off x="777240" y="2926080"/>
-            <a:ext cx="2286000" cy="822960"/>
-          </a:xfrm>
-          <a:prstGeom prst="rect">
-            <a:avLst/>
-          </a:prstGeom>
-          <a:noFill/>
-          <a:ln/>
-        </p:spPr>
-        <p:txBody>
-          <a:bodyPr wrap="square" lIns="0" tIns="0" rIns="0" bIns="0" rtlCol="0" anchor="t"/>
-          <a:lstStyle/>
-          <a:p>
-            <a:pPr indent="0" marL="0">
-              <a:buNone/>
-            </a:pPr>
-            <a:r>
-              <a:rPr lang="en-US" sz="1600" dirty="0">
-                <a:solidFill>
-                  <a:schemeClr val="accent5"/>
-                </a:solidFill>
-              </a:rPr>
-              <a:t>comprobaciones automáticas, todas pasan</a:t>
-            </a:r>
-            <a:endParaRPr lang="en-US" sz="1600" dirty="0"/>
-          </a:p>
-        </p:txBody>
-      </p:sp>
-      <p:sp>
-        <p:nvSpPr>
-          <p:cNvPr id="6" name="Dato validación 1"/>
-          <p:cNvSpPr/>
-          <p:nvPr/>
-        </p:nvSpPr>
-        <p:spPr>
-          <a:xfrm>
-            <a:off x="3566160" y="1325880"/>
-            <a:ext cx="2423160" cy="1417320"/>
-          </a:xfrm>
-          <a:prstGeom prst="roundRect">
-            <a:avLst>
-              <a:gd name="adj" fmla="val 7742"/>
-            </a:avLst>
-          </a:prstGeom>
-          <a:solidFill>
-            <a:schemeClr val="bg1"/>
-          </a:solidFill>
-          <a:ln w="12700">
-            <a:solidFill>
-              <a:schemeClr val="bg1"/>
-            </a:solidFill>
-            <a:prstDash val="solid"/>
-          </a:ln>
-          <a:effectLst>
-            <a:outerShdw sx="100000" sy="100000" kx="0" ky="0" algn="bl" rotWithShape="0" blurRad="101600" dist="25400" dir="5400000">
-              <a:srgbClr val="000000">
-                <a:alpha val="12000"/>
-              </a:srgbClr>
-            </a:outerShdw>
-          </a:effectLst>
-        </p:spPr>
-      </p:sp>
-      <p:sp>
-        <p:nvSpPr>
-          <p:cNvPr id="7" name="Val cifra 1"/>
-          <p:cNvSpPr txBox="1"/>
-          <p:nvPr/>
-        </p:nvSpPr>
-        <p:spPr>
-          <a:xfrm>
-            <a:off x="3767328" y="1435608"/>
-            <a:ext cx="2011680" cy="548640"/>
-          </a:xfrm>
-          <a:prstGeom prst="rect">
-            <a:avLst/>
-          </a:prstGeom>
-          <a:noFill/>
-          <a:ln/>
-        </p:spPr>
-        <p:txBody>
-          <a:bodyPr wrap="square" lIns="0" tIns="0" rIns="0" bIns="0" rtlCol="0" anchor="ctr"/>
-          <a:lstStyle/>
-          <a:p>
-            <a:pPr indent="0" marL="0">
-              <a:buNone/>
-            </a:pPr>
-            <a:r>
-              <a:rPr lang="en-US" sz="3200" b="1" dirty="0">
-                <a:solidFill>
-                  <a:schemeClr val="accent1"/>
-                </a:solidFill>
-                <a:latin typeface="Cambria" pitchFamily="34" charset="0"/>
-                <a:ea typeface="Cambria" pitchFamily="34" charset="-122"/>
-                <a:cs typeface="Cambria" pitchFamily="34" charset="-120"/>
-              </a:rPr>
-              <a:t>51</a:t>
-            </a:r>
-            <a:endParaRPr lang="en-US" sz="3200" dirty="0"/>
-          </a:p>
-        </p:txBody>
-      </p:sp>
-      <p:sp>
-        <p:nvSpPr>
-          <p:cNvPr id="8" name="Val texto 1"/>
-          <p:cNvSpPr txBox="1"/>
-          <p:nvPr/>
-        </p:nvSpPr>
-        <p:spPr>
-          <a:xfrm>
-            <a:off x="3767328" y="2039112"/>
-            <a:ext cx="2057400" cy="640080"/>
-          </a:xfrm>
-          <a:prstGeom prst="rect">
-            <a:avLst/>
-          </a:prstGeom>
-          <a:noFill/>
-          <a:ln/>
-        </p:spPr>
-        <p:txBody>
-          <a:bodyPr wrap="square" lIns="0" tIns="0" rIns="0" bIns="0" rtlCol="0" anchor="t"/>
-          <a:lstStyle/>
-          <a:p>
-            <a:pPr indent="0" marL="0">
-              <a:buNone/>
-            </a:pPr>
-            <a:r>
-              <a:rPr lang="en-US" sz="1400" dirty="0">
-                <a:solidFill>
-                  <a:schemeClr val="tx1"/>
-                </a:solidFill>
-              </a:rPr>
-              <a:t>tests unitarios y de componentes (Vitest)</a:t>
-            </a:r>
-            <a:endParaRPr lang="en-US" sz="1400" dirty="0"/>
-          </a:p>
-        </p:txBody>
-      </p:sp>
-      <p:sp>
-        <p:nvSpPr>
-          <p:cNvPr id="9" name="Dato validación 2"/>
-          <p:cNvSpPr/>
-          <p:nvPr/>
-        </p:nvSpPr>
-        <p:spPr>
-          <a:xfrm>
-            <a:off x="6172200" y="1325880"/>
-            <a:ext cx="2423160" cy="1417320"/>
-          </a:xfrm>
-          <a:prstGeom prst="roundRect">
-            <a:avLst>
-              <a:gd name="adj" fmla="val 7742"/>
-            </a:avLst>
-          </a:prstGeom>
-          <a:solidFill>
-            <a:schemeClr val="bg1"/>
-          </a:solidFill>
-          <a:ln w="12700">
-            <a:solidFill>
-              <a:schemeClr val="bg1"/>
-            </a:solidFill>
-            <a:prstDash val="solid"/>
-          </a:ln>
-          <a:effectLst>
-            <a:outerShdw sx="100000" sy="100000" kx="0" ky="0" algn="bl" rotWithShape="0" blurRad="101600" dist="25400" dir="5400000">
-              <a:srgbClr val="000000">
-                <a:alpha val="12000"/>
-              </a:srgbClr>
-            </a:outerShdw>
-          </a:effectLst>
-        </p:spPr>
-      </p:sp>
-      <p:sp>
-        <p:nvSpPr>
-          <p:cNvPr id="10" name="Val cifra 2"/>
-          <p:cNvSpPr txBox="1"/>
-          <p:nvPr/>
-        </p:nvSpPr>
-        <p:spPr>
-          <a:xfrm>
-            <a:off x="6373368" y="1435608"/>
-            <a:ext cx="2011680" cy="548640"/>
-          </a:xfrm>
-          <a:prstGeom prst="rect">
-            <a:avLst/>
-          </a:prstGeom>
-          <a:noFill/>
-          <a:ln/>
-        </p:spPr>
-        <p:txBody>
-          <a:bodyPr wrap="square" lIns="0" tIns="0" rIns="0" bIns="0" rtlCol="0" anchor="ctr"/>
-          <a:lstStyle/>
-          <a:p>
-            <a:pPr indent="0" marL="0">
-              <a:buNone/>
-            </a:pPr>
-            <a:r>
-              <a:rPr lang="en-US" sz="3200" b="1" dirty="0">
-                <a:solidFill>
-                  <a:schemeClr val="accent1"/>
-                </a:solidFill>
-                <a:latin typeface="Cambria" pitchFamily="34" charset="0"/>
-                <a:ea typeface="Cambria" pitchFamily="34" charset="-122"/>
-                <a:cs typeface="Cambria" pitchFamily="34" charset="-120"/>
-              </a:rPr>
-              <a:t>56</a:t>
-            </a:r>
-            <a:endParaRPr lang="en-US" sz="3200" dirty="0"/>
-          </a:p>
-        </p:txBody>
-      </p:sp>
-      <p:sp>
-        <p:nvSpPr>
-          <p:cNvPr id="11" name="Val texto 2"/>
-          <p:cNvSpPr txBox="1"/>
-          <p:nvPr/>
-        </p:nvSpPr>
-        <p:spPr>
-          <a:xfrm>
-            <a:off x="6373368" y="2039112"/>
-            <a:ext cx="2057400" cy="640080"/>
-          </a:xfrm>
-          <a:prstGeom prst="rect">
-            <a:avLst/>
-          </a:prstGeom>
-          <a:noFill/>
-          <a:ln/>
-        </p:spPr>
-        <p:txBody>
-          <a:bodyPr wrap="square" lIns="0" tIns="0" rIns="0" bIns="0" rtlCol="0" anchor="t"/>
-          <a:lstStyle/>
-          <a:p>
-            <a:pPr indent="0" marL="0">
-              <a:buNone/>
-            </a:pPr>
-            <a:r>
-              <a:rPr lang="en-US" sz="1400" dirty="0">
-                <a:solidFill>
-                  <a:schemeClr val="tx1"/>
-                </a:solidFill>
-              </a:rPr>
-              <a:t>pruebas e2e: 28 × 2 perfiles, Android e iPhone</a:t>
-            </a:r>
-            <a:endParaRPr lang="en-US" sz="1400" dirty="0"/>
-          </a:p>
-        </p:txBody>
-      </p:sp>
-      <p:sp>
-        <p:nvSpPr>
-          <p:cNvPr id="12" name="Dato validación 3"/>
-          <p:cNvSpPr/>
-          <p:nvPr/>
-        </p:nvSpPr>
-        <p:spPr>
-          <a:xfrm>
-            <a:off x="3566160" y="2926080"/>
-            <a:ext cx="2423160" cy="1417320"/>
-          </a:xfrm>
-          <a:prstGeom prst="roundRect">
-            <a:avLst>
-              <a:gd name="adj" fmla="val 7742"/>
-            </a:avLst>
-          </a:prstGeom>
-          <a:solidFill>
-            <a:schemeClr val="bg1"/>
-          </a:solidFill>
-          <a:ln w="12700">
-            <a:solidFill>
-              <a:schemeClr val="bg1"/>
-            </a:solidFill>
-            <a:prstDash val="solid"/>
-          </a:ln>
-          <a:effectLst>
-            <a:outerShdw sx="100000" sy="100000" kx="0" ky="0" algn="bl" rotWithShape="0" blurRad="101600" dist="25400" dir="5400000">
-              <a:srgbClr val="000000">
-                <a:alpha val="12000"/>
-              </a:srgbClr>
-            </a:outerShdw>
-          </a:effectLst>
-        </p:spPr>
-      </p:sp>
-      <p:sp>
-        <p:nvSpPr>
-          <p:cNvPr id="13" name="Val cifra 3"/>
-          <p:cNvSpPr txBox="1"/>
-          <p:nvPr/>
-        </p:nvSpPr>
-        <p:spPr>
-          <a:xfrm>
-            <a:off x="3767328" y="3035808"/>
-            <a:ext cx="2011680" cy="548640"/>
-          </a:xfrm>
-          <a:prstGeom prst="rect">
-            <a:avLst/>
-          </a:prstGeom>
-          <a:noFill/>
-          <a:ln/>
-        </p:spPr>
-        <p:txBody>
-          <a:bodyPr wrap="square" lIns="0" tIns="0" rIns="0" bIns="0" rtlCol="0" anchor="ctr"/>
-          <a:lstStyle/>
-          <a:p>
-            <a:pPr indent="0" marL="0">
-              <a:buNone/>
-            </a:pPr>
-            <a:r>
-              <a:rPr lang="en-US" sz="3200" b="1" dirty="0">
-                <a:solidFill>
-                  <a:schemeClr val="accent1"/>
-                </a:solidFill>
-                <a:latin typeface="Cambria" pitchFamily="34" charset="0"/>
-                <a:ea typeface="Cambria" pitchFamily="34" charset="-122"/>
-                <a:cs typeface="Cambria" pitchFamily="34" charset="-120"/>
-              </a:rPr>
-              <a:t>0</a:t>
-            </a:r>
-            <a:endParaRPr lang="en-US" sz="3200" dirty="0"/>
-          </a:p>
-        </p:txBody>
-      </p:sp>
-      <p:sp>
-        <p:nvSpPr>
-          <p:cNvPr id="14" name="Val texto 3"/>
-          <p:cNvSpPr txBox="1"/>
-          <p:nvPr/>
-        </p:nvSpPr>
-        <p:spPr>
-          <a:xfrm>
-            <a:off x="3767328" y="3639312"/>
-            <a:ext cx="2057400" cy="640080"/>
-          </a:xfrm>
-          <a:prstGeom prst="rect">
-            <a:avLst/>
-          </a:prstGeom>
-          <a:noFill/>
-          <a:ln/>
-        </p:spPr>
-        <p:txBody>
-          <a:bodyPr wrap="square" lIns="0" tIns="0" rIns="0" bIns="0" rtlCol="0" anchor="t"/>
-          <a:lstStyle/>
-          <a:p>
-            <a:pPr indent="0" marL="0">
-              <a:buNone/>
-            </a:pPr>
-            <a:r>
-              <a:rPr lang="en-US" sz="1400" dirty="0">
-                <a:solidFill>
-                  <a:schemeClr val="tx1"/>
-                </a:solidFill>
-              </a:rPr>
-              <a:t>violaciones serious o critical de axe en 6 pantallas</a:t>
-            </a:r>
-            <a:endParaRPr lang="en-US" sz="1400" dirty="0"/>
-          </a:p>
-        </p:txBody>
-      </p:sp>
-      <p:sp>
-        <p:nvSpPr>
-          <p:cNvPr id="15" name="Dato validación 4"/>
-          <p:cNvSpPr/>
-          <p:nvPr/>
-        </p:nvSpPr>
-        <p:spPr>
-          <a:xfrm>
-            <a:off x="6172200" y="2926080"/>
-            <a:ext cx="2423160" cy="1417320"/>
-          </a:xfrm>
-          <a:prstGeom prst="roundRect">
-            <a:avLst>
-              <a:gd name="adj" fmla="val 7742"/>
-            </a:avLst>
-          </a:prstGeom>
-          <a:solidFill>
-            <a:schemeClr val="bg1"/>
-          </a:solidFill>
-          <a:ln w="12700">
-            <a:solidFill>
-              <a:schemeClr val="bg1"/>
-            </a:solidFill>
-            <a:prstDash val="solid"/>
-          </a:ln>
-          <a:effectLst>
-            <a:outerShdw sx="100000" sy="100000" kx="0" ky="0" algn="bl" rotWithShape="0" blurRad="101600" dist="25400" dir="5400000">
-              <a:srgbClr val="000000">
-                <a:alpha val="12000"/>
-              </a:srgbClr>
-            </a:outerShdw>
-          </a:effectLst>
-        </p:spPr>
-      </p:sp>
-      <p:sp>
-        <p:nvSpPr>
-          <p:cNvPr id="16" name="Val cifra 4"/>
-          <p:cNvSpPr txBox="1"/>
-          <p:nvPr/>
-        </p:nvSpPr>
-        <p:spPr>
-          <a:xfrm>
-            <a:off x="6373368" y="3035808"/>
-            <a:ext cx="2011680" cy="548640"/>
-          </a:xfrm>
-          <a:prstGeom prst="rect">
-            <a:avLst/>
-          </a:prstGeom>
-          <a:noFill/>
-          <a:ln/>
-        </p:spPr>
-        <p:txBody>
-          <a:bodyPr wrap="square" lIns="0" tIns="0" rIns="0" bIns="0" rtlCol="0" anchor="ctr"/>
-          <a:lstStyle/>
-          <a:p>
-            <a:pPr indent="0" marL="0">
-              <a:buNone/>
-            </a:pPr>
-            <a:r>
-              <a:rPr lang="en-US" sz="3200" b="1" dirty="0">
-                <a:solidFill>
-                  <a:schemeClr val="accent1"/>
-                </a:solidFill>
-                <a:latin typeface="Cambria" pitchFamily="34" charset="0"/>
-                <a:ea typeface="Cambria" pitchFamily="34" charset="-122"/>
-                <a:cs typeface="Cambria" pitchFamily="34" charset="-120"/>
-              </a:rPr>
-              <a:t>15/15</a:t>
-            </a:r>
-            <a:endParaRPr lang="en-US" sz="3200" dirty="0"/>
-          </a:p>
-        </p:txBody>
-      </p:sp>
-      <p:sp>
-        <p:nvSpPr>
-          <p:cNvPr id="17" name="Val texto 4"/>
-          <p:cNvSpPr txBox="1"/>
-          <p:nvPr/>
-        </p:nvSpPr>
-        <p:spPr>
-          <a:xfrm>
-            <a:off x="6373368" y="3639312"/>
-            <a:ext cx="2057400" cy="640080"/>
-          </a:xfrm>
-          <a:prstGeom prst="rect">
-            <a:avLst/>
-          </a:prstGeom>
-          <a:noFill/>
-          <a:ln/>
-        </p:spPr>
-        <p:txBody>
-          <a:bodyPr wrap="square" lIns="0" tIns="0" rIns="0" bIns="0" rtlCol="0" anchor="t"/>
-          <a:lstStyle/>
-          <a:p>
-            <a:pPr indent="0" marL="0">
-              <a:buNone/>
-            </a:pPr>
-            <a:r>
-              <a:rPr lang="en-US" sz="1400" dirty="0">
-                <a:solidFill>
-                  <a:schemeClr val="tx1"/>
-                </a:solidFill>
-              </a:rPr>
-              <a:t>pares de color que cumplen el contraste</a:t>
-            </a:r>
-            <a:endParaRPr lang="en-US" sz="1400" dirty="0"/>
-          </a:p>
-        </p:txBody>
-      </p:sp>
-      <p:sp>
-        <p:nvSpPr>
-          <p:cNvPr id="18" name="Nota validación"/>
-          <p:cNvSpPr txBox="1"/>
-          <p:nvPr/>
-        </p:nvSpPr>
-        <p:spPr>
-          <a:xfrm>
-            <a:off x="548640" y="4462272"/>
-            <a:ext cx="8046720" cy="228600"/>
-          </a:xfrm>
-          <a:prstGeom prst="rect">
-            <a:avLst/>
-          </a:prstGeom>
-          <a:noFill/>
-          <a:ln/>
-        </p:spPr>
-        <p:txBody>
-          <a:bodyPr wrap="square" lIns="0" tIns="0" rIns="0" bIns="0" rtlCol="0" anchor="ctr"/>
-          <a:lstStyle/>
-          <a:p>
-            <a:pPr indent="0" marL="0">
-              <a:buNone/>
-            </a:pPr>
-            <a:r>
-              <a:rPr lang="en-US" sz="1200" dirty="0">
-                <a:solidFill>
-                  <a:schemeClr val="accent6"/>
-                </a:solidFill>
-              </a:rPr>
-              <a:t>Validado el 16/10/2026. Cada test lleva el ID del requisito que comprueba.</a:t>
-            </a:r>
-            <a:endParaRPr lang="en-US" sz="1200" dirty="0"/>
-          </a:p>
-        </p:txBody>
-      </p:sp>
-      <p:sp>
-        <p:nvSpPr>
-          <p:cNvPr id="25" name="Slide Number Placeholder 0"/>
-          <p:cNvSpPr>
-            <a:spLocks noGrp="1"/>
-          </p:cNvSpPr>
-          <p:nvPr>
-            <p:ph type="sldNum" sz="quarter" idx="4294967295"/>
-          </p:nvPr>
-        </p:nvSpPr>
-        <p:spPr>
-          <a:xfrm>
-            <a:off x="8138160" y="4736592"/>
-            <a:ext cx="457200" cy="274320"/>
-          </a:xfrm>
-          <a:prstGeom prst="rect">
-            <a:avLst/>
-          </a:prstGeom>
-          <a:extLst>
-            <a:ext uri="{C572A759-6A51-4108-AA02-DFA0A04FC94B}">
-              <ma14:wrappingTextBoxFlag xmlns:ma14="http://schemas.microsoft.com/office/mac/drawingml/2011/main" val="0"/>
-            </a:ext>
-          </a:extLst>
-        </p:spPr>
-        <p:txBody>
-          <a:bodyPr/>
-          <a:lstStyle>
-            <a:lvl1pPr>
-              <a:defRPr sz="1000">
-                <a:solidFill>
-                  <a:schemeClr val="accent6"/>
-                </a:solidFill>
-              </a:defRPr>
-            </a:lvl1pPr>
-          </a:lstStyle>
-          <a:p>
-            <a:pPr algn="r"/>
-            <a:fld id="{F7021451-1387-4CA6-816F-3879F97B5CBC}" type="slidenum">
-              <a:rPr b="0" lang="en-US"/>
-              <a:t>8</a:t>
             </a:fld>
             <a:endParaRPr lang="en-US"/>
           </a:p>

</xml_diff>